<commit_message>
Synthesising Sources FC v2: 5 slides, added courseware example + summary
</commit_message>
<xml_diff>
--- a/Synthesising_Sources_FC.pptx
+++ b/Synthesising_Sources_FC.pptx
@@ -9,6 +9,7 @@
     <p:sldId id="257" r:id="rId8"/>
     <p:sldId id="258" r:id="rId9"/>
     <p:sldId id="259" r:id="rId10"/>
+    <p:sldId id="260" r:id="rId11"/>
   </p:sldIdLst>
   <p:sldSz cx="12191695" cy="6858000" type="screen4x3"/>
   <p:notesSz cx="6858000" cy="9144000"/>
@@ -4170,8 +4171,8 @@
         </p:nvSpPr>
         <p:spPr>
           <a:xfrm>
-            <a:off x="685800" y="1280160"/>
-            <a:ext cx="3383280" cy="3291840"/>
+            <a:off x="685800" y="1143000"/>
+            <a:ext cx="3383280" cy="1417320"/>
           </a:xfrm>
           <a:prstGeom prst="rect">
             <a:avLst/>
@@ -4213,8 +4214,8 @@
         </p:nvSpPr>
         <p:spPr>
           <a:xfrm>
-            <a:off x="914400" y="1554480"/>
-            <a:ext cx="2926080" cy="548640"/>
+            <a:off x="914400" y="1463040"/>
+            <a:ext cx="2926080" cy="731520"/>
           </a:xfrm>
           <a:prstGeom prst="rect">
             <a:avLst/>
@@ -4249,8 +4250,8 @@
         </p:nvSpPr>
         <p:spPr>
           <a:xfrm>
-            <a:off x="3887992224000" y="2377440"/>
-            <a:ext cx="548640" cy="731520"/>
+            <a:off x="3887992224000" y="1508760"/>
+            <a:ext cx="548640" cy="548640"/>
           </a:xfrm>
           <a:prstGeom prst="rect">
             <a:avLst/>
@@ -4264,7 +4265,7 @@
           <a:lstStyle/>
           <a:p>
             <a:pPr algn="ctr">
-              <a:defRPr sz="4000" b="1">
+              <a:defRPr sz="3600" b="1">
                 <a:solidFill>
                   <a:srgbClr val="30124E"/>
                 </a:solidFill>
@@ -4285,8 +4286,8 @@
         </p:nvSpPr>
         <p:spPr>
           <a:xfrm>
-            <a:off x="4983480" y="1280160"/>
-            <a:ext cx="3383280" cy="3291840"/>
+            <a:off x="4983480" y="1143000"/>
+            <a:ext cx="3383280" cy="1417320"/>
           </a:xfrm>
           <a:prstGeom prst="rect">
             <a:avLst/>
@@ -4328,8 +4329,8 @@
         </p:nvSpPr>
         <p:spPr>
           <a:xfrm>
-            <a:off x="5212080" y="1554480"/>
-            <a:ext cx="2926080" cy="548640"/>
+            <a:off x="5212080" y="1463040"/>
+            <a:ext cx="2926080" cy="731520"/>
           </a:xfrm>
           <a:prstGeom prst="rect">
             <a:avLst/>
@@ -4364,8 +4365,8 @@
         </p:nvSpPr>
         <p:spPr>
           <a:xfrm>
-            <a:off x="8549640" y="2377440"/>
-            <a:ext cx="548640" cy="731520"/>
+            <a:off x="8549640" y="1508760"/>
+            <a:ext cx="548640" cy="548640"/>
           </a:xfrm>
           <a:prstGeom prst="rect">
             <a:avLst/>
@@ -4379,7 +4380,7 @@
           <a:lstStyle/>
           <a:p>
             <a:pPr algn="ctr">
-              <a:defRPr sz="4000" b="1">
+              <a:defRPr sz="3600" b="1">
                 <a:solidFill>
                   <a:srgbClr val="30124E"/>
                 </a:solidFill>
@@ -4400,8 +4401,8 @@
         </p:nvSpPr>
         <p:spPr>
           <a:xfrm>
-            <a:off x="9281160" y="1280160"/>
-            <a:ext cx="2560320" cy="3291840"/>
+            <a:off x="9281160" y="1143000"/>
+            <a:ext cx="2560320" cy="1417320"/>
           </a:xfrm>
           <a:prstGeom prst="rect">
             <a:avLst/>
@@ -4443,8 +4444,8 @@
         </p:nvSpPr>
         <p:spPr>
           <a:xfrm>
-            <a:off x="9509760" y="1554480"/>
-            <a:ext cx="2103120" cy="548640"/>
+            <a:off x="9509760" y="1463040"/>
+            <a:ext cx="2103120" cy="731520"/>
           </a:xfrm>
           <a:prstGeom prst="rect">
             <a:avLst/>
@@ -4466,25 +4467,64 @@
               </a:defRPr>
             </a:pPr>
             <a:r>
-              <a:t>③  Your</a:t>
-            </a:r>
-            <a:br/>
-            <a:r>
-              <a:t>    Voice</a:t>
-            </a:r>
-          </a:p>
-        </p:txBody>
-      </p:sp>
-      <p:sp>
-        <p:nvSpPr>
-          <p:cNvPr id="14" name="TextBox 13"/>
+              <a:t>③  Your Voice</a:t>
+            </a:r>
+          </a:p>
+        </p:txBody>
+      </p:sp>
+      <p:sp>
+        <p:nvSpPr>
+          <p:cNvPr id="14" name="Rectangle 13"/>
+          <p:cNvSpPr/>
+          <p:nvPr/>
+        </p:nvSpPr>
+        <p:spPr>
+          <a:xfrm>
+            <a:off x="685800" y="2834640"/>
+            <a:ext cx="10789920" cy="457200"/>
+          </a:xfrm>
+          <a:prstGeom prst="rect">
+            <a:avLst/>
+          </a:prstGeom>
+          <a:solidFill>
+            <a:srgbClr val="FFF3BF"/>
+          </a:solidFill>
+          <a:ln>
+            <a:noFill/>
+          </a:ln>
+        </p:spPr>
+        <p:style>
+          <a:lnRef idx="1">
+            <a:schemeClr val="accent1"/>
+          </a:lnRef>
+          <a:fillRef idx="3">
+            <a:schemeClr val="accent1"/>
+          </a:fillRef>
+          <a:effectRef idx="2">
+            <a:schemeClr val="accent1"/>
+          </a:effectRef>
+          <a:fontRef idx="minor">
+            <a:schemeClr val="lt1"/>
+          </a:fontRef>
+        </p:style>
+        <p:txBody>
+          <a:bodyPr rtlCol="0" anchor="ctr"/>
+          <a:lstStyle/>
+          <a:p>
+            <a:pPr algn="ctr"/>
+          </a:p>
+        </p:txBody>
+      </p:sp>
+      <p:sp>
+        <p:nvSpPr>
+          <p:cNvPr id="15" name="TextBox 14"/>
           <p:cNvSpPr txBox="1"/>
           <p:nvPr/>
         </p:nvSpPr>
         <p:spPr>
           <a:xfrm>
-            <a:off x="9509760" y="2743200"/>
-            <a:ext cx="2103120" cy="1280160"/>
+            <a:off x="822960" y="2852928"/>
+            <a:ext cx="10515600" cy="411480"/>
           </a:xfrm>
           <a:prstGeom prst="rect">
             <a:avLst/>
@@ -4498,29 +4538,72 @@
           <a:lstStyle/>
           <a:p>
             <a:pPr algn="l">
-              <a:defRPr sz="2400" b="1">
-                <a:solidFill>
-                  <a:srgbClr val="999999"/>
+              <a:defRPr sz="1600" b="1">
+                <a:solidFill>
+                  <a:srgbClr val="1A1A1A"/>
                 </a:solidFill>
                 <a:latin typeface="Calibri"/>
               </a:defRPr>
             </a:pPr>
             <a:r>
-              <a:t>Conclusion</a:t>
-            </a:r>
-          </a:p>
-        </p:txBody>
-      </p:sp>
-      <p:sp>
-        <p:nvSpPr>
-          <p:cNvPr id="15" name="TextBox 14"/>
+              <a:t>Tattooed applicants face discrimination in the workplace …</a:t>
+            </a:r>
+          </a:p>
+        </p:txBody>
+      </p:sp>
+      <p:sp>
+        <p:nvSpPr>
+          <p:cNvPr id="16" name="Rectangle 15"/>
+          <p:cNvSpPr/>
+          <p:nvPr/>
+        </p:nvSpPr>
+        <p:spPr>
+          <a:xfrm>
+            <a:off x="685800" y="3383280"/>
+            <a:ext cx="10789920" cy="1188720"/>
+          </a:xfrm>
+          <a:prstGeom prst="rect">
+            <a:avLst/>
+          </a:prstGeom>
+          <a:solidFill>
+            <a:srgbClr val="DBE5F1"/>
+          </a:solidFill>
+          <a:ln>
+            <a:noFill/>
+          </a:ln>
+        </p:spPr>
+        <p:style>
+          <a:lnRef idx="1">
+            <a:schemeClr val="accent1"/>
+          </a:lnRef>
+          <a:fillRef idx="3">
+            <a:schemeClr val="accent1"/>
+          </a:fillRef>
+          <a:effectRef idx="2">
+            <a:schemeClr val="accent1"/>
+          </a:effectRef>
+          <a:fontRef idx="minor">
+            <a:schemeClr val="lt1"/>
+          </a:fontRef>
+        </p:style>
+        <p:txBody>
+          <a:bodyPr rtlCol="0" anchor="ctr"/>
+          <a:lstStyle/>
+          <a:p>
+            <a:pPr algn="ctr"/>
+          </a:p>
+        </p:txBody>
+      </p:sp>
+      <p:sp>
+        <p:nvSpPr>
+          <p:cNvPr id="17" name="TextBox 16"/>
           <p:cNvSpPr txBox="1"/>
           <p:nvPr/>
         </p:nvSpPr>
         <p:spPr>
           <a:xfrm>
-            <a:off x="685800" y="5074920"/>
-            <a:ext cx="10972800" cy="457200"/>
+            <a:off x="822960" y="3401568"/>
+            <a:ext cx="10515600" cy="1097280"/>
           </a:xfrm>
           <a:prstGeom prst="rect">
             <a:avLst/>
@@ -4533,23 +4616,146 @@
           </a:bodyPr>
           <a:lstStyle/>
           <a:p>
-            <a:pPr algn="ctr">
-              <a:defRPr sz="2200" b="1">
-                <a:solidFill>
-                  <a:srgbClr val="30124E"/>
+            <a:pPr algn="l">
+              <a:defRPr sz="1600" b="1">
+                <a:solidFill>
+                  <a:srgbClr val="1A1A1A"/>
                 </a:solidFill>
                 <a:latin typeface="Calibri"/>
               </a:defRPr>
             </a:pPr>
             <a:r>
-              <a:t>Topic  →  Citations  →  Your synthesised argument</a:t>
-            </a:r>
-          </a:p>
-        </p:txBody>
-      </p:sp>
-      <p:sp>
-        <p:nvSpPr>
-          <p:cNvPr id="16" name="TextBox 15"/>
+              <a:t>Bekhor et al. (1995): managers averse to tattooed employees</a:t>
+            </a:r>
+            <a:br/>
+            <a:r>
+              <a:t>Swanger (2006): 80%+ HR managers — negative feelings</a:t>
+            </a:r>
+            <a:br/>
+            <a:r>
+              <a:t>Miller et al. (2009): co-workers avoid tattooed teammates</a:t>
+            </a:r>
+          </a:p>
+        </p:txBody>
+      </p:sp>
+      <p:sp>
+        <p:nvSpPr>
+          <p:cNvPr id="18" name="Rectangle 17"/>
+          <p:cNvSpPr/>
+          <p:nvPr/>
+        </p:nvSpPr>
+        <p:spPr>
+          <a:xfrm>
+            <a:off x="685800" y="4663440"/>
+            <a:ext cx="10789920" cy="457200"/>
+          </a:xfrm>
+          <a:prstGeom prst="rect">
+            <a:avLst/>
+          </a:prstGeom>
+          <a:solidFill>
+            <a:srgbClr val="E2EFDA"/>
+          </a:solidFill>
+          <a:ln>
+            <a:noFill/>
+          </a:ln>
+        </p:spPr>
+        <p:style>
+          <a:lnRef idx="1">
+            <a:schemeClr val="accent1"/>
+          </a:lnRef>
+          <a:fillRef idx="3">
+            <a:schemeClr val="accent1"/>
+          </a:fillRef>
+          <a:effectRef idx="2">
+            <a:schemeClr val="accent1"/>
+          </a:effectRef>
+          <a:fontRef idx="minor">
+            <a:schemeClr val="lt1"/>
+          </a:fontRef>
+        </p:style>
+        <p:txBody>
+          <a:bodyPr rtlCol="0" anchor="ctr"/>
+          <a:lstStyle/>
+          <a:p>
+            <a:pPr algn="ctr"/>
+          </a:p>
+        </p:txBody>
+      </p:sp>
+      <p:sp>
+        <p:nvSpPr>
+          <p:cNvPr id="19" name="TextBox 18"/>
+          <p:cNvSpPr txBox="1"/>
+          <p:nvPr/>
+        </p:nvSpPr>
+        <p:spPr>
+          <a:xfrm>
+            <a:off x="822960" y="4681728"/>
+            <a:ext cx="10515600" cy="411480"/>
+          </a:xfrm>
+          <a:prstGeom prst="rect">
+            <a:avLst/>
+          </a:prstGeom>
+          <a:noFill/>
+        </p:spPr>
+        <p:txBody>
+          <a:bodyPr wrap="square">
+            <a:spAutoFit/>
+          </a:bodyPr>
+          <a:lstStyle/>
+          <a:p>
+            <a:pPr algn="l">
+              <a:defRPr sz="1600" b="1">
+                <a:solidFill>
+                  <a:srgbClr val="1A1A1A"/>
+                </a:solidFill>
+                <a:latin typeface="Calibri"/>
+              </a:defRPr>
+            </a:pPr>
+            <a:r>
+              <a:t>→  HR managers hold widely antagonistic views toward body art.</a:t>
+            </a:r>
+          </a:p>
+        </p:txBody>
+      </p:sp>
+      <p:sp>
+        <p:nvSpPr>
+          <p:cNvPr id="20" name="TextBox 19"/>
+          <p:cNvSpPr txBox="1"/>
+          <p:nvPr/>
+        </p:nvSpPr>
+        <p:spPr>
+          <a:xfrm>
+            <a:off x="685800" y="5257800"/>
+            <a:ext cx="10515600" cy="365760"/>
+          </a:xfrm>
+          <a:prstGeom prst="rect">
+            <a:avLst/>
+          </a:prstGeom>
+          <a:noFill/>
+        </p:spPr>
+        <p:txBody>
+          <a:bodyPr wrap="square">
+            <a:spAutoFit/>
+          </a:bodyPr>
+          <a:lstStyle/>
+          <a:p>
+            <a:pPr algn="l">
+              <a:defRPr sz="1100" b="0">
+                <a:solidFill>
+                  <a:srgbClr val="999999"/>
+                </a:solidFill>
+                <a:latin typeface="Calibri"/>
+              </a:defRPr>
+            </a:pPr>
+            <a:r>
+              <a:t>French et al. (2018), Human Relations, 72(5)</a:t>
+            </a:r>
+          </a:p>
+        </p:txBody>
+      </p:sp>
+      <p:sp>
+        <p:nvSpPr>
+          <p:cNvPr id="21" name="TextBox 20"/>
           <p:cNvSpPr txBox="1"/>
           <p:nvPr/>
         </p:nvSpPr>
@@ -5180,6 +5386,683 @@
             </a:pPr>
             <a:r>
               <a:t>Voice + evidence = synthesis.</a:t>
+            </a:r>
+          </a:p>
+        </p:txBody>
+      </p:sp>
+    </p:spTree>
+  </p:cSld>
+  <p:clrMapOvr>
+    <a:masterClrMapping/>
+  </p:clrMapOvr>
+</p:sld>
+</file>
+
+<file path=ppt/slides/slide5.xml><?xml version="1.0" encoding="utf-8"?>
+<p:sld xmlns:a="http://schemas.openxmlformats.org/drawingml/2006/main" xmlns:p="http://schemas.openxmlformats.org/presentationml/2006/main" xmlns:r="http://schemas.openxmlformats.org/officeDocument/2006/relationships">
+  <p:cSld>
+    <p:spTree>
+      <p:nvGrpSpPr>
+        <p:cNvPr id="1" name=""/>
+        <p:cNvGrpSpPr/>
+        <p:nvPr/>
+      </p:nvGrpSpPr>
+      <p:grpSpPr/>
+      <p:sp>
+        <p:nvSpPr>
+          <p:cNvPr id="2" name="Rectangle 1"/>
+          <p:cNvSpPr/>
+          <p:nvPr/>
+        </p:nvSpPr>
+        <p:spPr>
+          <a:xfrm>
+            <a:off x="0" y="0"/>
+            <a:ext cx="411480" cy="6858000"/>
+          </a:xfrm>
+          <a:prstGeom prst="rect">
+            <a:avLst/>
+          </a:prstGeom>
+          <a:solidFill>
+            <a:srgbClr val="502379"/>
+          </a:solidFill>
+          <a:ln>
+            <a:noFill/>
+          </a:ln>
+        </p:spPr>
+        <p:style>
+          <a:lnRef idx="1">
+            <a:schemeClr val="accent1"/>
+          </a:lnRef>
+          <a:fillRef idx="3">
+            <a:schemeClr val="accent1"/>
+          </a:fillRef>
+          <a:effectRef idx="2">
+            <a:schemeClr val="accent1"/>
+          </a:effectRef>
+          <a:fontRef idx="minor">
+            <a:schemeClr val="lt1"/>
+          </a:fontRef>
+        </p:style>
+        <p:txBody>
+          <a:bodyPr rtlCol="0" anchor="ctr"/>
+          <a:lstStyle/>
+          <a:p>
+            <a:pPr algn="ctr"/>
+          </a:p>
+        </p:txBody>
+      </p:sp>
+      <p:sp>
+        <p:nvSpPr>
+          <p:cNvPr id="3" name="Rectangle 2"/>
+          <p:cNvSpPr/>
+          <p:nvPr/>
+        </p:nvSpPr>
+        <p:spPr>
+          <a:xfrm>
+            <a:off x="0" y="6035040"/>
+            <a:ext cx="12191695" cy="822960"/>
+          </a:xfrm>
+          <a:prstGeom prst="rect">
+            <a:avLst/>
+          </a:prstGeom>
+          <a:solidFill>
+            <a:srgbClr val="F5F0FA"/>
+          </a:solidFill>
+          <a:ln>
+            <a:noFill/>
+          </a:ln>
+        </p:spPr>
+        <p:style>
+          <a:lnRef idx="1">
+            <a:schemeClr val="accent1"/>
+          </a:lnRef>
+          <a:fillRef idx="3">
+            <a:schemeClr val="accent1"/>
+          </a:fillRef>
+          <a:effectRef idx="2">
+            <a:schemeClr val="accent1"/>
+          </a:effectRef>
+          <a:fontRef idx="minor">
+            <a:schemeClr val="lt1"/>
+          </a:fontRef>
+        </p:style>
+        <p:txBody>
+          <a:bodyPr rtlCol="0" anchor="ctr"/>
+          <a:lstStyle/>
+          <a:p>
+            <a:pPr algn="ctr"/>
+          </a:p>
+        </p:txBody>
+      </p:sp>
+      <p:sp>
+        <p:nvSpPr>
+          <p:cNvPr id="4" name="TextBox 3"/>
+          <p:cNvSpPr txBox="1"/>
+          <p:nvPr/>
+        </p:nvSpPr>
+        <p:spPr>
+          <a:xfrm>
+            <a:off x="11247120" y="6446520"/>
+            <a:ext cx="822960" cy="320040"/>
+          </a:xfrm>
+          <a:prstGeom prst="rect">
+            <a:avLst/>
+          </a:prstGeom>
+          <a:noFill/>
+        </p:spPr>
+        <p:txBody>
+          <a:bodyPr wrap="square">
+            <a:spAutoFit/>
+          </a:bodyPr>
+          <a:lstStyle/>
+          <a:p>
+            <a:pPr algn="r">
+              <a:defRPr sz="1200" b="0">
+                <a:solidFill>
+                  <a:srgbClr val="999999"/>
+                </a:solidFill>
+                <a:latin typeface="Calibri"/>
+              </a:defRPr>
+            </a:pPr>
+            <a:r>
+              <a:t>5</a:t>
+            </a:r>
+          </a:p>
+        </p:txBody>
+      </p:sp>
+      <p:sp>
+        <p:nvSpPr>
+          <p:cNvPr id="5" name="TextBox 4"/>
+          <p:cNvSpPr txBox="1"/>
+          <p:nvPr/>
+        </p:nvSpPr>
+        <p:spPr>
+          <a:xfrm>
+            <a:off x="685800" y="274320"/>
+            <a:ext cx="10515600" cy="640080"/>
+          </a:xfrm>
+          <a:prstGeom prst="rect">
+            <a:avLst/>
+          </a:prstGeom>
+          <a:noFill/>
+        </p:spPr>
+        <p:txBody>
+          <a:bodyPr wrap="square">
+            <a:spAutoFit/>
+          </a:bodyPr>
+          <a:lstStyle/>
+          <a:p>
+            <a:pPr algn="l">
+              <a:defRPr sz="3000" b="1">
+                <a:solidFill>
+                  <a:srgbClr val="30124E"/>
+                </a:solidFill>
+                <a:latin typeface="Calibri"/>
+              </a:defRPr>
+            </a:pPr>
+            <a:r>
+              <a:t>Summary</a:t>
+            </a:r>
+          </a:p>
+        </p:txBody>
+      </p:sp>
+      <p:sp>
+        <p:nvSpPr>
+          <p:cNvPr id="6" name="Rectangle 5"/>
+          <p:cNvSpPr/>
+          <p:nvPr/>
+        </p:nvSpPr>
+        <p:spPr>
+          <a:xfrm>
+            <a:off x="685800" y="1463040"/>
+            <a:ext cx="3429000" cy="3200400"/>
+          </a:xfrm>
+          <a:prstGeom prst="rect">
+            <a:avLst/>
+          </a:prstGeom>
+          <a:solidFill>
+            <a:srgbClr val="F5F0FA"/>
+          </a:solidFill>
+          <a:ln>
+            <a:noFill/>
+          </a:ln>
+        </p:spPr>
+        <p:style>
+          <a:lnRef idx="1">
+            <a:schemeClr val="accent1"/>
+          </a:lnRef>
+          <a:fillRef idx="3">
+            <a:schemeClr val="accent1"/>
+          </a:fillRef>
+          <a:effectRef idx="2">
+            <a:schemeClr val="accent1"/>
+          </a:effectRef>
+          <a:fontRef idx="minor">
+            <a:schemeClr val="lt1"/>
+          </a:fontRef>
+        </p:style>
+        <p:txBody>
+          <a:bodyPr rtlCol="0" anchor="ctr"/>
+          <a:lstStyle/>
+          <a:p>
+            <a:pPr algn="ctr"/>
+          </a:p>
+        </p:txBody>
+      </p:sp>
+      <p:sp>
+        <p:nvSpPr>
+          <p:cNvPr id="7" name="TextBox 6"/>
+          <p:cNvSpPr txBox="1"/>
+          <p:nvPr/>
+        </p:nvSpPr>
+        <p:spPr>
+          <a:xfrm>
+            <a:off x="914400" y="1645920"/>
+            <a:ext cx="457200" cy="548640"/>
+          </a:xfrm>
+          <a:prstGeom prst="rect">
+            <a:avLst/>
+          </a:prstGeom>
+          <a:noFill/>
+        </p:spPr>
+        <p:txBody>
+          <a:bodyPr wrap="square">
+            <a:spAutoFit/>
+          </a:bodyPr>
+          <a:lstStyle/>
+          <a:p>
+            <a:pPr algn="l">
+              <a:defRPr sz="3600" b="1">
+                <a:solidFill>
+                  <a:srgbClr val="30124E"/>
+                </a:solidFill>
+                <a:latin typeface="Calibri"/>
+              </a:defRPr>
+            </a:pPr>
+            <a:r>
+              <a:t>①</a:t>
+            </a:r>
+          </a:p>
+        </p:txBody>
+      </p:sp>
+      <p:sp>
+        <p:nvSpPr>
+          <p:cNvPr id="8" name="TextBox 7"/>
+          <p:cNvSpPr txBox="1"/>
+          <p:nvPr/>
+        </p:nvSpPr>
+        <p:spPr>
+          <a:xfrm>
+            <a:off x="1508760" y="1737360"/>
+            <a:ext cx="2377440" cy="548640"/>
+          </a:xfrm>
+          <a:prstGeom prst="rect">
+            <a:avLst/>
+          </a:prstGeom>
+          <a:noFill/>
+        </p:spPr>
+        <p:txBody>
+          <a:bodyPr wrap="square">
+            <a:spAutoFit/>
+          </a:bodyPr>
+          <a:lstStyle/>
+          <a:p>
+            <a:pPr algn="l">
+              <a:defRPr sz="2400" b="1">
+                <a:solidFill>
+                  <a:srgbClr val="30124E"/>
+                </a:solidFill>
+                <a:latin typeface="Calibri"/>
+              </a:defRPr>
+            </a:pPr>
+            <a:r>
+              <a:t>Sources → Synthesis</a:t>
+            </a:r>
+          </a:p>
+        </p:txBody>
+      </p:sp>
+      <p:sp>
+        <p:nvSpPr>
+          <p:cNvPr id="9" name="TextBox 8"/>
+          <p:cNvSpPr txBox="1"/>
+          <p:nvPr/>
+        </p:nvSpPr>
+        <p:spPr>
+          <a:xfrm>
+            <a:off x="1508760" y="2560320"/>
+            <a:ext cx="2377440" cy="1828800"/>
+          </a:xfrm>
+          <a:prstGeom prst="rect">
+            <a:avLst/>
+          </a:prstGeom>
+          <a:noFill/>
+        </p:spPr>
+        <p:txBody>
+          <a:bodyPr wrap="square">
+            <a:spAutoFit/>
+          </a:bodyPr>
+          <a:lstStyle/>
+          <a:p>
+            <a:pPr algn="l">
+              <a:defRPr sz="2000" b="1">
+                <a:solidFill>
+                  <a:srgbClr val="1A1A1A"/>
+                </a:solidFill>
+                <a:latin typeface="Calibri"/>
+              </a:defRPr>
+            </a:pPr>
+            <a:r>
+              <a:t>Cite + paraphrase</a:t>
+            </a:r>
+            <a:br/>
+            <a:r>
+              <a:t>→ Connect + evaluate</a:t>
+            </a:r>
+          </a:p>
+        </p:txBody>
+      </p:sp>
+      <p:sp>
+        <p:nvSpPr>
+          <p:cNvPr id="10" name="Rectangle 9"/>
+          <p:cNvSpPr/>
+          <p:nvPr/>
+        </p:nvSpPr>
+        <p:spPr>
+          <a:xfrm>
+            <a:off x="4434840" y="1463040"/>
+            <a:ext cx="3429000" cy="3200400"/>
+          </a:xfrm>
+          <a:prstGeom prst="rect">
+            <a:avLst/>
+          </a:prstGeom>
+          <a:solidFill>
+            <a:srgbClr val="F5F0FA"/>
+          </a:solidFill>
+          <a:ln>
+            <a:noFill/>
+          </a:ln>
+        </p:spPr>
+        <p:style>
+          <a:lnRef idx="1">
+            <a:schemeClr val="accent1"/>
+          </a:lnRef>
+          <a:fillRef idx="3">
+            <a:schemeClr val="accent1"/>
+          </a:fillRef>
+          <a:effectRef idx="2">
+            <a:schemeClr val="accent1"/>
+          </a:effectRef>
+          <a:fontRef idx="minor">
+            <a:schemeClr val="lt1"/>
+          </a:fontRef>
+        </p:style>
+        <p:txBody>
+          <a:bodyPr rtlCol="0" anchor="ctr"/>
+          <a:lstStyle/>
+          <a:p>
+            <a:pPr algn="ctr"/>
+          </a:p>
+        </p:txBody>
+      </p:sp>
+      <p:sp>
+        <p:nvSpPr>
+          <p:cNvPr id="11" name="TextBox 10"/>
+          <p:cNvSpPr txBox="1"/>
+          <p:nvPr/>
+        </p:nvSpPr>
+        <p:spPr>
+          <a:xfrm>
+            <a:off x="4663440" y="1645920"/>
+            <a:ext cx="457200" cy="548640"/>
+          </a:xfrm>
+          <a:prstGeom prst="rect">
+            <a:avLst/>
+          </a:prstGeom>
+          <a:noFill/>
+        </p:spPr>
+        <p:txBody>
+          <a:bodyPr wrap="square">
+            <a:spAutoFit/>
+          </a:bodyPr>
+          <a:lstStyle/>
+          <a:p>
+            <a:pPr algn="l">
+              <a:defRPr sz="3600" b="1">
+                <a:solidFill>
+                  <a:srgbClr val="30124E"/>
+                </a:solidFill>
+                <a:latin typeface="Calibri"/>
+              </a:defRPr>
+            </a:pPr>
+            <a:r>
+              <a:t>②</a:t>
+            </a:r>
+          </a:p>
+        </p:txBody>
+      </p:sp>
+      <p:sp>
+        <p:nvSpPr>
+          <p:cNvPr id="12" name="TextBox 11"/>
+          <p:cNvSpPr txBox="1"/>
+          <p:nvPr/>
+        </p:nvSpPr>
+        <p:spPr>
+          <a:xfrm>
+            <a:off x="5257800" y="1737360"/>
+            <a:ext cx="2377440" cy="548640"/>
+          </a:xfrm>
+          <a:prstGeom prst="rect">
+            <a:avLst/>
+          </a:prstGeom>
+          <a:noFill/>
+        </p:spPr>
+        <p:txBody>
+          <a:bodyPr wrap="square">
+            <a:spAutoFit/>
+          </a:bodyPr>
+          <a:lstStyle/>
+          <a:p>
+            <a:pPr algn="l">
+              <a:defRPr sz="2400" b="1">
+                <a:solidFill>
+                  <a:srgbClr val="30124E"/>
+                </a:solidFill>
+                <a:latin typeface="Calibri"/>
+              </a:defRPr>
+            </a:pPr>
+            <a:r>
+              <a:t>3-Colour</a:t>
+            </a:r>
+          </a:p>
+        </p:txBody>
+      </p:sp>
+      <p:sp>
+        <p:nvSpPr>
+          <p:cNvPr id="13" name="TextBox 12"/>
+          <p:cNvSpPr txBox="1"/>
+          <p:nvPr/>
+        </p:nvSpPr>
+        <p:spPr>
+          <a:xfrm>
+            <a:off x="5257800" y="2560320"/>
+            <a:ext cx="2377440" cy="1828800"/>
+          </a:xfrm>
+          <a:prstGeom prst="rect">
+            <a:avLst/>
+          </a:prstGeom>
+          <a:noFill/>
+        </p:spPr>
+        <p:txBody>
+          <a:bodyPr wrap="square">
+            <a:spAutoFit/>
+          </a:bodyPr>
+          <a:lstStyle/>
+          <a:p>
+            <a:pPr algn="l">
+              <a:defRPr sz="2000" b="1">
+                <a:solidFill>
+                  <a:srgbClr val="1A1A1A"/>
+                </a:solidFill>
+                <a:latin typeface="Calibri"/>
+              </a:defRPr>
+            </a:pPr>
+            <a:r>
+              <a:t>Topic  →  Citations</a:t>
+            </a:r>
+            <a:br/>
+            <a:r>
+              <a:t>→  Your Voice</a:t>
+            </a:r>
+          </a:p>
+        </p:txBody>
+      </p:sp>
+      <p:sp>
+        <p:nvSpPr>
+          <p:cNvPr id="14" name="Rectangle 13"/>
+          <p:cNvSpPr/>
+          <p:nvPr/>
+        </p:nvSpPr>
+        <p:spPr>
+          <a:xfrm>
+            <a:off x="8183879" y="1463040"/>
+            <a:ext cx="3429000" cy="3200400"/>
+          </a:xfrm>
+          <a:prstGeom prst="rect">
+            <a:avLst/>
+          </a:prstGeom>
+          <a:solidFill>
+            <a:srgbClr val="F5F0FA"/>
+          </a:solidFill>
+          <a:ln>
+            <a:noFill/>
+          </a:ln>
+        </p:spPr>
+        <p:style>
+          <a:lnRef idx="1">
+            <a:schemeClr val="accent1"/>
+          </a:lnRef>
+          <a:fillRef idx="3">
+            <a:schemeClr val="accent1"/>
+          </a:fillRef>
+          <a:effectRef idx="2">
+            <a:schemeClr val="accent1"/>
+          </a:effectRef>
+          <a:fontRef idx="minor">
+            <a:schemeClr val="lt1"/>
+          </a:fontRef>
+        </p:style>
+        <p:txBody>
+          <a:bodyPr rtlCol="0" anchor="ctr"/>
+          <a:lstStyle/>
+          <a:p>
+            <a:pPr algn="ctr"/>
+          </a:p>
+        </p:txBody>
+      </p:sp>
+      <p:sp>
+        <p:nvSpPr>
+          <p:cNvPr id="15" name="TextBox 14"/>
+          <p:cNvSpPr txBox="1"/>
+          <p:nvPr/>
+        </p:nvSpPr>
+        <p:spPr>
+          <a:xfrm>
+            <a:off x="8412479" y="1645920"/>
+            <a:ext cx="457200" cy="548640"/>
+          </a:xfrm>
+          <a:prstGeom prst="rect">
+            <a:avLst/>
+          </a:prstGeom>
+          <a:noFill/>
+        </p:spPr>
+        <p:txBody>
+          <a:bodyPr wrap="square">
+            <a:spAutoFit/>
+          </a:bodyPr>
+          <a:lstStyle/>
+          <a:p>
+            <a:pPr algn="l">
+              <a:defRPr sz="3600" b="1">
+                <a:solidFill>
+                  <a:srgbClr val="30124E"/>
+                </a:solidFill>
+                <a:latin typeface="Calibri"/>
+              </a:defRPr>
+            </a:pPr>
+            <a:r>
+              <a:t>③</a:t>
+            </a:r>
+          </a:p>
+        </p:txBody>
+      </p:sp>
+      <p:sp>
+        <p:nvSpPr>
+          <p:cNvPr id="16" name="TextBox 15"/>
+          <p:cNvSpPr txBox="1"/>
+          <p:nvPr/>
+        </p:nvSpPr>
+        <p:spPr>
+          <a:xfrm>
+            <a:off x="9006839" y="1737360"/>
+            <a:ext cx="2377440" cy="548640"/>
+          </a:xfrm>
+          <a:prstGeom prst="rect">
+            <a:avLst/>
+          </a:prstGeom>
+          <a:noFill/>
+        </p:spPr>
+        <p:txBody>
+          <a:bodyPr wrap="square">
+            <a:spAutoFit/>
+          </a:bodyPr>
+          <a:lstStyle/>
+          <a:p>
+            <a:pPr algn="l">
+              <a:defRPr sz="2400" b="1">
+                <a:solidFill>
+                  <a:srgbClr val="30124E"/>
+                </a:solidFill>
+                <a:latin typeface="Calibri"/>
+              </a:defRPr>
+            </a:pPr>
+            <a:r>
+              <a:t>Your Role</a:t>
+            </a:r>
+          </a:p>
+        </p:txBody>
+      </p:sp>
+      <p:sp>
+        <p:nvSpPr>
+          <p:cNvPr id="17" name="TextBox 16"/>
+          <p:cNvSpPr txBox="1"/>
+          <p:nvPr/>
+        </p:nvSpPr>
+        <p:spPr>
+          <a:xfrm>
+            <a:off x="9006839" y="2560320"/>
+            <a:ext cx="2377440" cy="1828800"/>
+          </a:xfrm>
+          <a:prstGeom prst="rect">
+            <a:avLst/>
+          </a:prstGeom>
+          <a:noFill/>
+        </p:spPr>
+        <p:txBody>
+          <a:bodyPr wrap="square">
+            <a:spAutoFit/>
+          </a:bodyPr>
+          <a:lstStyle/>
+          <a:p>
+            <a:pPr algn="l">
+              <a:defRPr sz="2000" b="1">
+                <a:solidFill>
+                  <a:srgbClr val="1A1A1A"/>
+                </a:solidFill>
+                <a:latin typeface="Calibri"/>
+              </a:defRPr>
+            </a:pPr>
+            <a:r>
+              <a:t>Weave evidence</a:t>
+            </a:r>
+            <a:br/>
+            <a:r>
+              <a:t>Lead with argument</a:t>
+            </a:r>
+          </a:p>
+        </p:txBody>
+      </p:sp>
+      <p:sp>
+        <p:nvSpPr>
+          <p:cNvPr id="18" name="TextBox 17"/>
+          <p:cNvSpPr txBox="1"/>
+          <p:nvPr/>
+        </p:nvSpPr>
+        <p:spPr>
+          <a:xfrm>
+            <a:off x="685800" y="6108192"/>
+            <a:ext cx="10515600" cy="640080"/>
+          </a:xfrm>
+          <a:prstGeom prst="rect">
+            <a:avLst/>
+          </a:prstGeom>
+          <a:noFill/>
+        </p:spPr>
+        <p:txBody>
+          <a:bodyPr wrap="square">
+            <a:spAutoFit/>
+          </a:bodyPr>
+          <a:lstStyle/>
+          <a:p>
+            <a:pPr algn="l">
+              <a:defRPr sz="1800" b="1">
+                <a:solidFill>
+                  <a:srgbClr val="30124E"/>
+                </a:solidFill>
+                <a:latin typeface="Calibri"/>
+              </a:defRPr>
+            </a:pPr>
+            <a:r>
+              <a:t>Synthesis = your voice + evidence, woven together.</a:t>
             </a:r>
           </a:p>
         </p:txBody>

</xml_diff>